<commit_message>
Update project attribution to solo developer Naga Surya Dinesh
- Update documentation (README, proposal, checklist, setup guide)
- Update PPTX generation script and HTML presentation deck
- Ensure all attribution reflects solo development for Pushpak Grand Challenge 2026

Co-Authored-By: Claude Code <noreply@anthropic.com>
</commit_message>
<xml_diff>
--- a/AeroMesh_Swarm_Stage1_Presentation.pptx
+++ b/AeroMesh_Swarm_Stage1_Presentation.pptx
@@ -3404,7 +3404,7 @@
               </a:defRPr>
             </a:pPr>
             <a:r>
-              <a:t>Team / Author: Naga Surya Dinesh (Lead) &amp; AeroMesh Development Team</a:t>
+              <a:t>Author / Developer: Naga Surya Dinesh (Solo Developer)</a:t>
             </a:r>
           </a:p>
           <a:p>
@@ -4891,7 +4891,7 @@
               </a:defRPr>
             </a:pPr>
             <a:r>
-              <a:t>Team Lead: Naga Surya Dinesh  |  Email: nagasuryadinesh@gmail.com  |  Affiliation: Autonomous Robotics &amp; Swarm Lab</a:t>
+              <a:t>Author: Naga Surya Dinesh (Solo Developer)  |  Email: nagasuryadinesh@gmail.com  |  Affiliation: Autonomous Robotics &amp; Swarm Lab</a:t>
             </a:r>
             <a:br/>
             <a:r>

</xml_diff>